<commit_message>
Update June 2026 balance sheet presentation
Replit-Commit-Author: Agent
</commit_message>
<xml_diff>
--- a/ledgerlm/ledgerlm/exports/LedgerLM-Balance-Sheet-Jun-2026.pptx
+++ b/ledgerlm/ledgerlm/exports/LedgerLM-Balance-Sheet-Jun-2026.pptx
@@ -148,17 +148,18 @@
               <a:lstStyle/>
               <a:p>
                 <a:pPr>
-                  <a:defRPr b="0" i="0" strike="noStrike" sz="1200" u="none">
+                  <a:defRPr b="1" i="0" strike="noStrike" sz="700" u="none">
                     <a:solidFill>
-                      <a:srgbClr val="000000"/>
+                      <a:srgbClr val="FFFFFF"/>
                     </a:solidFill>
-                    <a:latin typeface="Arial"/>
+                    <a:latin typeface="Aptos"/>
                   </a:defRPr>
                 </a:pPr>
               </a:p>
             </c:txPr>
+            <c:dLblPos val="inEnd"/>
             <c:showLegendKey val="0"/>
-            <c:showVal val="0"/>
+            <c:showVal val="1"/>
             <c:showCatName val="0"/>
             <c:showSerName val="0"/>
             <c:showPercent val="0"/>
@@ -255,17 +256,18 @@
               <a:lstStyle/>
               <a:p>
                 <a:pPr>
-                  <a:defRPr b="0" i="0" strike="noStrike" sz="1200" u="none">
+                  <a:defRPr b="1" i="0" strike="noStrike" sz="700" u="none">
                     <a:solidFill>
-                      <a:srgbClr val="000000"/>
+                      <a:srgbClr val="FFFFFF"/>
                     </a:solidFill>
-                    <a:latin typeface="Arial"/>
+                    <a:latin typeface="Aptos"/>
                   </a:defRPr>
                 </a:pPr>
               </a:p>
             </c:txPr>
+            <c:dLblPos val="inEnd"/>
             <c:showLegendKey val="0"/>
-            <c:showVal val="0"/>
+            <c:showVal val="1"/>
             <c:showCatName val="0"/>
             <c:showSerName val="0"/>
             <c:showPercent val="0"/>
@@ -341,17 +343,18 @@
             <a:lstStyle/>
             <a:p>
               <a:pPr>
-                <a:defRPr b="0" i="0" strike="noStrike" sz="1200" u="none">
+                <a:defRPr b="1" i="0" strike="noStrike" sz="700" u="none">
                   <a:solidFill>
-                    <a:srgbClr val="000000"/>
+                    <a:srgbClr val="FFFFFF"/>
                   </a:solidFill>
-                  <a:latin typeface="Arial"/>
+                  <a:latin typeface="Aptos"/>
                 </a:defRPr>
               </a:pPr>
             </a:p>
           </c:txPr>
+          <c:dLblPos val="inEnd"/>
           <c:showLegendKey val="0"/>
-          <c:showVal val="0"/>
+          <c:showVal val="1"/>
           <c:showCatName val="0"/>
           <c:showSerName val="0"/>
           <c:showPercent val="0"/>
@@ -523,17 +526,18 @@
               <a:lstStyle/>
               <a:p>
                 <a:pPr>
-                  <a:defRPr b="0" i="0" strike="noStrike" sz="1200" u="none">
+                  <a:defRPr b="1" i="0" strike="noStrike" sz="700" u="none">
                     <a:solidFill>
-                      <a:srgbClr val="000000"/>
+                      <a:srgbClr val="FFFFFF"/>
                     </a:solidFill>
-                    <a:latin typeface="Arial"/>
+                    <a:latin typeface="Aptos"/>
                   </a:defRPr>
                 </a:pPr>
               </a:p>
             </c:txPr>
+            <c:dLblPos val="inEnd"/>
             <c:showLegendKey val="0"/>
-            <c:showVal val="0"/>
+            <c:showVal val="1"/>
             <c:showCatName val="0"/>
             <c:showSerName val="0"/>
             <c:showPercent val="0"/>
@@ -624,17 +628,18 @@
               <a:lstStyle/>
               <a:p>
                 <a:pPr>
-                  <a:defRPr b="0" i="0" strike="noStrike" sz="1200" u="none">
+                  <a:defRPr b="1" i="0" strike="noStrike" sz="700" u="none">
                     <a:solidFill>
-                      <a:srgbClr val="000000"/>
+                      <a:srgbClr val="FFFFFF"/>
                     </a:solidFill>
-                    <a:latin typeface="Arial"/>
+                    <a:latin typeface="Aptos"/>
                   </a:defRPr>
                 </a:pPr>
               </a:p>
             </c:txPr>
+            <c:dLblPos val="inEnd"/>
             <c:showLegendKey val="0"/>
-            <c:showVal val="0"/>
+            <c:showVal val="1"/>
             <c:showCatName val="0"/>
             <c:showSerName val="0"/>
             <c:showPercent val="0"/>
@@ -704,17 +709,18 @@
             <a:lstStyle/>
             <a:p>
               <a:pPr>
-                <a:defRPr b="0" i="0" strike="noStrike" sz="1200" u="none">
+                <a:defRPr b="1" i="0" strike="noStrike" sz="700" u="none">
                   <a:solidFill>
-                    <a:srgbClr val="000000"/>
+                    <a:srgbClr val="FFFFFF"/>
                   </a:solidFill>
-                  <a:latin typeface="Arial"/>
+                  <a:latin typeface="Aptos"/>
                 </a:defRPr>
               </a:pPr>
             </a:p>
           </c:txPr>
+          <c:dLblPos val="inEnd"/>
           <c:showLegendKey val="0"/>
-          <c:showVal val="0"/>
+          <c:showVal val="1"/>
           <c:showCatName val="0"/>
           <c:showSerName val="0"/>
           <c:showPercent val="0"/>
@@ -2318,7 +2324,7 @@
                 <a:ea typeface="Aptos" pitchFamily="34" charset="-122"/>
                 <a:cs typeface="Aptos" pitchFamily="34" charset="-120"/>
               </a:rPr>
-              <a:t>Source: 1790156941511-e39171c6683f-MBR BS_Input_15Aug (2).xlsx · comparison uses the latest earlier loaded period</a:t>
+              <a:t>Source: Dedicated Balance Sheet cube · comparison uses the latest earlier loaded period</a:t>
             </a:r>
             <a:endParaRPr lang="en-US" sz="650" dirty="0"/>
           </a:p>
@@ -2952,7 +2958,7 @@
                 <a:ea typeface="Aptos" pitchFamily="34" charset="-122"/>
                 <a:cs typeface="Aptos" pitchFamily="34" charset="-120"/>
               </a:rPr>
-              <a:t>Source: 1790156941511-e39171c6683f-MBR BS_Input_15Aug (2).xlsx · comparison uses the latest earlier loaded period</a:t>
+              <a:t>Source: Dedicated Balance Sheet cube · comparison uses the latest earlier loaded period</a:t>
             </a:r>
             <a:endParaRPr lang="en-US" sz="650" dirty="0"/>
           </a:p>

</xml_diff>

<commit_message>
Update balance sheet presentation for June 2026
Replit-Commit-Author: Agent
</commit_message>
<xml_diff>
--- a/ledgerlm/ledgerlm/exports/LedgerLM-Balance-Sheet-Jun-2026.pptx
+++ b/ledgerlm/ledgerlm/exports/LedgerLM-Balance-Sheet-Jun-2026.pptx
@@ -148,16 +148,16 @@
               <a:lstStyle/>
               <a:p>
                 <a:pPr>
-                  <a:defRPr b="1" i="0" strike="noStrike" sz="700" u="none">
+                  <a:defRPr b="0" i="0" strike="noStrike" sz="800" u="none">
                     <a:solidFill>
-                      <a:srgbClr val="FFFFFF"/>
+                      <a:srgbClr val="222222"/>
                     </a:solidFill>
                     <a:latin typeface="Aptos"/>
                   </a:defRPr>
                 </a:pPr>
               </a:p>
             </c:txPr>
-            <c:dLblPos val="inEnd"/>
+            <c:dLblPos val="outEnd"/>
             <c:showLegendKey val="0"/>
             <c:showVal val="1"/>
             <c:showCatName val="0"/>
@@ -256,16 +256,16 @@
               <a:lstStyle/>
               <a:p>
                 <a:pPr>
-                  <a:defRPr b="1" i="0" strike="noStrike" sz="700" u="none">
+                  <a:defRPr b="0" i="0" strike="noStrike" sz="800" u="none">
                     <a:solidFill>
-                      <a:srgbClr val="FFFFFF"/>
+                      <a:srgbClr val="222222"/>
                     </a:solidFill>
                     <a:latin typeface="Aptos"/>
                   </a:defRPr>
                 </a:pPr>
               </a:p>
             </c:txPr>
-            <c:dLblPos val="inEnd"/>
+            <c:dLblPos val="outEnd"/>
             <c:showLegendKey val="0"/>
             <c:showVal val="1"/>
             <c:showCatName val="0"/>
@@ -343,16 +343,16 @@
             <a:lstStyle/>
             <a:p>
               <a:pPr>
-                <a:defRPr b="1" i="0" strike="noStrike" sz="700" u="none">
+                <a:defRPr b="0" i="0" strike="noStrike" sz="800" u="none">
                   <a:solidFill>
-                    <a:srgbClr val="FFFFFF"/>
+                    <a:srgbClr val="222222"/>
                   </a:solidFill>
                   <a:latin typeface="Aptos"/>
                 </a:defRPr>
               </a:pPr>
             </a:p>
           </c:txPr>
-          <c:dLblPos val="inEnd"/>
+          <c:dLblPos val="outEnd"/>
           <c:showLegendKey val="0"/>
           <c:showVal val="1"/>
           <c:showCatName val="0"/>
@@ -412,6 +412,7 @@
         <c:axId val="2094734552"/>
         <c:scaling>
           <c:orientation val="minMax"/>
+          <c:max val="29097.392956884403"/>
         </c:scaling>
         <c:delete val="0"/>
         <c:axPos val="l"/>
@@ -526,16 +527,16 @@
               <a:lstStyle/>
               <a:p>
                 <a:pPr>
-                  <a:defRPr b="1" i="0" strike="noStrike" sz="700" u="none">
+                  <a:defRPr b="0" i="0" strike="noStrike" sz="800" u="none">
                     <a:solidFill>
-                      <a:srgbClr val="FFFFFF"/>
+                      <a:srgbClr val="222222"/>
                     </a:solidFill>
                     <a:latin typeface="Aptos"/>
                   </a:defRPr>
                 </a:pPr>
               </a:p>
             </c:txPr>
-            <c:dLblPos val="inEnd"/>
+            <c:dLblPos val="outEnd"/>
             <c:showLegendKey val="0"/>
             <c:showVal val="1"/>
             <c:showCatName val="0"/>
@@ -628,16 +629,16 @@
               <a:lstStyle/>
               <a:p>
                 <a:pPr>
-                  <a:defRPr b="1" i="0" strike="noStrike" sz="700" u="none">
+                  <a:defRPr b="0" i="0" strike="noStrike" sz="800" u="none">
                     <a:solidFill>
-                      <a:srgbClr val="FFFFFF"/>
+                      <a:srgbClr val="222222"/>
                     </a:solidFill>
                     <a:latin typeface="Aptos"/>
                   </a:defRPr>
                 </a:pPr>
               </a:p>
             </c:txPr>
-            <c:dLblPos val="inEnd"/>
+            <c:dLblPos val="outEnd"/>
             <c:showLegendKey val="0"/>
             <c:showVal val="1"/>
             <c:showCatName val="0"/>
@@ -709,16 +710,16 @@
             <a:lstStyle/>
             <a:p>
               <a:pPr>
-                <a:defRPr b="1" i="0" strike="noStrike" sz="700" u="none">
+                <a:defRPr b="0" i="0" strike="noStrike" sz="800" u="none">
                   <a:solidFill>
-                    <a:srgbClr val="FFFFFF"/>
+                    <a:srgbClr val="222222"/>
                   </a:solidFill>
                   <a:latin typeface="Aptos"/>
                 </a:defRPr>
               </a:pPr>
             </a:p>
           </c:txPr>
-          <c:dLblPos val="inEnd"/>
+          <c:dLblPos val="outEnd"/>
           <c:showLegendKey val="0"/>
           <c:showVal val="1"/>
           <c:showCatName val="0"/>
@@ -778,6 +779,7 @@
         <c:axId val="2094734552"/>
         <c:scaling>
           <c:orientation val="minMax"/>
+          <c:max val="68434.3121073364"/>
         </c:scaling>
         <c:delete val="0"/>
         <c:axPos val="l"/>

</xml_diff>